<commit_message>
Remove 120 minutes box from Capstone Format slide
Co-Authored-By: Claude Opus 4.6 (1M context) <noreply@anthropic.com>
</commit_message>
<xml_diff>
--- a/public/claude-code-basecamp-slides.pptx
+++ b/public/claude-code-basecamp-slides.pptx
@@ -16303,47 +16303,6 @@
             <a:spAutoFit/>
           </a:bodyPr>
           <a:lstStyle/>
-          <a:p>
-            <a:pPr>
-              <a:lnSpc>
-                <a:spcPts val="2565"/>
-              </a:lnSpc>
-              <a:spcBef>
-                <a:spcPts val="200"/>
-              </a:spcBef>
-              <a:spcAft>
-                <a:spcPts val="600"/>
-              </a:spcAft>
-              <a:defRPr sz="1900">
-                <a:solidFill>
-                  <a:srgbClr val="141413"/>
-                </a:solidFill>
-                <a:latin typeface="Calibri"/>
-              </a:defRPr>
-            </a:pPr>
-            <a:r>
-              <a:t>120 minutes. Fully integrated. No safety net.</a:t>
-            </a:r>
-          </a:p>
-          <a:p>
-            <a:pPr>
-              <a:lnSpc>
-                <a:spcPts val="2565"/>
-              </a:lnSpc>
-              <a:spcBef>
-                <a:spcPts val="200"/>
-              </a:spcBef>
-              <a:spcAft>
-                <a:spcPts val="600"/>
-              </a:spcAft>
-              <a:defRPr sz="1900">
-                <a:solidFill>
-                  <a:srgbClr val="141413"/>
-                </a:solidFill>
-                <a:latin typeface="Calibri"/>
-              </a:defRPr>
-            </a:pPr>
-          </a:p>
           <a:p>
             <a:pPr>
               <a:lnSpc>

</xml_diff>